<commit_message>
Correct task figure labels in grouped PowerPoint source and exports
</commit_message>
<xml_diff>
--- a/figures/editable/01_时序综述图件/20_Task_Contracts_RSI_Layout.pptx
+++ b/figures/editable/01_时序综述图件/20_Task_Contracts_RSI_Layout.pptx
@@ -1937,7 +1937,7 @@
                   <a:ea typeface="Cambria"/>
                   <a:cs typeface="Cambria"/>
                 </a:rPr>
-                <a:t>forecast y_t</a:t>
+                <a:t>input</a:t>
               </a:r>
               <a:endParaRPr sz="2300"/>
             </a:p>
@@ -1988,7 +1988,7 @@
                   <a:ea typeface="Cambria"/>
                   <a:cs typeface="Cambria"/>
                 </a:rPr>
-                <a:t>forecast y_{t+h}</a:t>
+                <a:t>prediction</a:t>
               </a:r>
               <a:endParaRPr sz="1160"/>
             </a:p>
@@ -2090,7 +2090,7 @@
                   <a:ea typeface="Cambria"/>
                   <a:cs typeface="Cambria"/>
                 </a:rPr>
-                <a:t>same harness</a:t>
+                <a:t>forecast</a:t>
               </a:r>
               <a:endParaRPr sz="2200"/>
             </a:p>
@@ -2141,7 +2141,7 @@
                   <a:ea typeface="Cambria"/>
                   <a:cs typeface="Cambria"/>
                 </a:rPr>
-                <a:t>new task</a:t>
+                <a:t>future horizon</a:t>
               </a:r>
               <a:endParaRPr sz="1700"/>
             </a:p>
@@ -2396,7 +2396,7 @@
                   <a:ea typeface="Cambria"/>
                   <a:cs typeface="Cambria"/>
                 </a:rPr>
-                <a:t>H_t → H_{t+1}</a:t>
+                <a:t>transform</a:t>
               </a:r>
               <a:endParaRPr sz="2300"/>
             </a:p>
@@ -2447,7 +2447,7 @@
                   <a:ea typeface="Cambria"/>
                   <a:cs typeface="Cambria"/>
                 </a:rPr>
-                <a:t>Agent + temporal state</a:t>
+                <a:t>training views</a:t>
               </a:r>
               <a:endParaRPr sz="2200"/>
             </a:p>
@@ -2498,7 +2498,7 @@
                   <a:ea typeface="Cambria"/>
                   <a:cs typeface="Cambria"/>
                 </a:rPr>
-                <a:t>temporal memory</a:t>
+                <a:t>utility</a:t>
               </a:r>
               <a:endParaRPr sz="2300"/>
             </a:p>
@@ -2549,7 +2549,7 @@
                   <a:ea typeface="Cambria"/>
                   <a:cs typeface="Cambria"/>
                 </a:rPr>
-                <a:t>task output</a:t>
+                <a:t>evidence</a:t>
               </a:r>
               <a:endParaRPr sz="2300"/>
             </a:p>
@@ -2600,7 +2600,7 @@
                   <a:ea typeface="Cambria"/>
                   <a:cs typeface="Cambria"/>
                 </a:rPr>
-                <a:t>updated forecast</a:t>
+                <a:t>diagnosis</a:t>
               </a:r>
               <a:endParaRPr sz="2200"/>
             </a:p>
@@ -2651,7 +2651,7 @@
                   <a:ea typeface="Cambria"/>
                   <a:cs typeface="Cambria"/>
                 </a:rPr>
-                <a:t>task output</a:t>
+                <a:t>event interval</a:t>
               </a:r>
               <a:endParaRPr sz="2300"/>
             </a:p>
@@ -2702,7 +2702,7 @@
                   <a:ea typeface="Cambria"/>
                   <a:cs typeface="Cambria"/>
                 </a:rPr>
-                <a:t>task contract</a:t>
+                <a:t>risk</a:t>
               </a:r>
               <a:endParaRPr sz="2300"/>
             </a:p>
@@ -2804,7 +2804,7 @@
                   <a:ea typeface="Cambria"/>
                   <a:cs typeface="Cambria"/>
                 </a:rPr>
-                <a:t>next task episode</a:t>
+                <a:t>selected action</a:t>
               </a:r>
               <a:endParaRPr sz="2000"/>
             </a:p>
@@ -2855,7 +2855,7 @@
                   <a:ea typeface="Cambria"/>
                   <a:cs typeface="Cambria"/>
                 </a:rPr>
-                <a:t>new module record</a:t>
+                <a:t>outcome feedback</a:t>
               </a:r>
               <a:endParaRPr sz="1160"/>
             </a:p>
@@ -2906,7 +2906,7 @@
                   <a:ea typeface="Cambria"/>
                   <a:cs typeface="Cambria"/>
                 </a:rPr>
-                <a:t>retain</a:t>
+                <a:t>review</a:t>
               </a:r>
               <a:endParaRPr sz="1700"/>
             </a:p>
@@ -2957,7 +2957,7 @@
                   <a:ea typeface="Cambria"/>
                   <a:cs typeface="Cambria"/>
                 </a:rPr>
-                <a:t>retain</a:t>
+                <a:t>review</a:t>
               </a:r>
               <a:endParaRPr sz="1700"/>
             </a:p>
@@ -3008,7 +3008,7 @@
                   <a:ea typeface="Cambria"/>
                   <a:cs typeface="Cambria"/>
                 </a:rPr>
-                <a:t>task-bound</a:t>
+                <a:t>forecast</a:t>
               </a:r>
               <a:endParaRPr sz="2000"/>
             </a:p>
@@ -3059,7 +3059,7 @@
                   <a:ea typeface="Cambria"/>
                   <a:cs typeface="Cambria"/>
                 </a:rPr>
-                <a:t>cross-task reuse</a:t>
+                <a:t>validate</a:t>
               </a:r>
               <a:endParaRPr sz="1700"/>
             </a:p>

</xml_diff>